<commit_message>
Updated presentation update, in .pptx and printed .pdf version
</commit_message>
<xml_diff>
--- a/UPDATE_CharAnalysis_20260624.pptx
+++ b/UPDATE_CharAnalysis_20260624.pptx
@@ -126,7 +126,7 @@
 <p1510:revInfo xmlns:a="http://schemas.openxmlformats.org/drawingml/2006/main" xmlns:r="http://schemas.openxmlformats.org/officeDocument/2006/relationships" xmlns:p1510="http://schemas.microsoft.com/office/powerpoint/2015/10/main">
   <p1510:revLst>
     <p1510:client id="{03B02DB9-72E0-483F-A06B-1210728967F7}" v="51" dt="2026-06-24T23:03:37.965"/>
-    <p1510:client id="{3DA4FEC4-CBFF-43B4-B4CE-024434E20B07}" v="4" dt="2026-06-25T03:17:16.945"/>
+    <p1510:client id="{3DA4FEC4-CBFF-43B4-B4CE-024434E20B07}" v="13" dt="2026-06-25T03:54:55.106"/>
   </p1510:revLst>
 </p1510:revInfo>
 </file>
@@ -797,13 +797,13 @@
   </pc:docChgLst>
   <pc:docChgLst>
     <pc:chgData name="Higuera, Philip" userId="7d9b71f7-bf10-494e-8cb3-2ed11b44844b" providerId="ADAL" clId="{50F7E95B-CBEE-4D68-902A-C9C37096BF45}"/>
-    <pc:docChg chg="modSld">
-      <pc:chgData name="Higuera, Philip" userId="7d9b71f7-bf10-494e-8cb3-2ed11b44844b" providerId="ADAL" clId="{50F7E95B-CBEE-4D68-902A-C9C37096BF45}" dt="2026-06-25T03:36:29.945" v="129" actId="1076"/>
+    <pc:docChg chg="undo custSel modSld">
+      <pc:chgData name="Higuera, Philip" userId="7d9b71f7-bf10-494e-8cb3-2ed11b44844b" providerId="ADAL" clId="{50F7E95B-CBEE-4D68-902A-C9C37096BF45}" dt="2026-06-25T03:58:39.114" v="493" actId="6549"/>
       <pc:docMkLst>
         <pc:docMk/>
       </pc:docMkLst>
-      <pc:sldChg chg="addSp modSp mod">
-        <pc:chgData name="Higuera, Philip" userId="7d9b71f7-bf10-494e-8cb3-2ed11b44844b" providerId="ADAL" clId="{50F7E95B-CBEE-4D68-902A-C9C37096BF45}" dt="2026-06-25T03:36:29.945" v="129" actId="1076"/>
+      <pc:sldChg chg="addSp modSp mod modTransition">
+        <pc:chgData name="Higuera, Philip" userId="7d9b71f7-bf10-494e-8cb3-2ed11b44844b" providerId="ADAL" clId="{50F7E95B-CBEE-4D68-902A-C9C37096BF45}" dt="2026-06-25T03:50:40.017" v="231" actId="20577"/>
         <pc:sldMkLst>
           <pc:docMk/>
           <pc:sldMk cId="0" sldId="256"/>
@@ -817,7 +817,7 @@
           </ac:spMkLst>
         </pc:spChg>
         <pc:spChg chg="mod">
-          <ac:chgData name="Higuera, Philip" userId="7d9b71f7-bf10-494e-8cb3-2ed11b44844b" providerId="ADAL" clId="{50F7E95B-CBEE-4D68-902A-C9C37096BF45}" dt="2026-06-25T03:36:14.210" v="127" actId="20577"/>
+          <ac:chgData name="Higuera, Philip" userId="7d9b71f7-bf10-494e-8cb3-2ed11b44844b" providerId="ADAL" clId="{50F7E95B-CBEE-4D68-902A-C9C37096BF45}" dt="2026-06-25T03:50:40.017" v="231" actId="20577"/>
           <ac:spMkLst>
             <pc:docMk/>
             <pc:sldMk cId="0" sldId="256"/>
@@ -825,7 +825,7 @@
           </ac:spMkLst>
         </pc:spChg>
         <pc:picChg chg="add mod">
-          <ac:chgData name="Higuera, Philip" userId="7d9b71f7-bf10-494e-8cb3-2ed11b44844b" providerId="ADAL" clId="{50F7E95B-CBEE-4D68-902A-C9C37096BF45}" dt="2026-06-25T03:36:29.945" v="129" actId="1076"/>
+          <ac:chgData name="Higuera, Philip" userId="7d9b71f7-bf10-494e-8cb3-2ed11b44844b" providerId="ADAL" clId="{50F7E95B-CBEE-4D68-902A-C9C37096BF45}" dt="2026-06-25T03:50:30.993" v="226" actId="1076"/>
           <ac:picMkLst>
             <pc:docMk/>
             <pc:sldMk cId="0" sldId="256"/>
@@ -833,8 +833,8 @@
           </ac:picMkLst>
         </pc:picChg>
       </pc:sldChg>
-      <pc:sldChg chg="modSp mod">
-        <pc:chgData name="Higuera, Philip" userId="7d9b71f7-bf10-494e-8cb3-2ed11b44844b" providerId="ADAL" clId="{50F7E95B-CBEE-4D68-902A-C9C37096BF45}" dt="2026-06-25T03:14:22.652" v="26" actId="20577"/>
+      <pc:sldChg chg="modSp mod modTransition">
+        <pc:chgData name="Higuera, Philip" userId="7d9b71f7-bf10-494e-8cb3-2ed11b44844b" providerId="ADAL" clId="{50F7E95B-CBEE-4D68-902A-C9C37096BF45}" dt="2026-06-25T03:43:25.329" v="130"/>
         <pc:sldMkLst>
           <pc:docMk/>
           <pc:sldMk cId="0" sldId="257"/>
@@ -848,8 +848,8 @@
           </ac:spMkLst>
         </pc:spChg>
       </pc:sldChg>
-      <pc:sldChg chg="modSp mod">
-        <pc:chgData name="Higuera, Philip" userId="7d9b71f7-bf10-494e-8cb3-2ed11b44844b" providerId="ADAL" clId="{50F7E95B-CBEE-4D68-902A-C9C37096BF45}" dt="2026-06-25T03:14:39.378" v="33" actId="20577"/>
+      <pc:sldChg chg="modSp mod modTransition">
+        <pc:chgData name="Higuera, Philip" userId="7d9b71f7-bf10-494e-8cb3-2ed11b44844b" providerId="ADAL" clId="{50F7E95B-CBEE-4D68-902A-C9C37096BF45}" dt="2026-06-25T03:43:25.329" v="130"/>
         <pc:sldMkLst>
           <pc:docMk/>
           <pc:sldMk cId="0" sldId="258"/>
@@ -860,6 +860,102 @@
             <pc:docMk/>
             <pc:sldMk cId="0" sldId="258"/>
             <ac:spMk id="2" creationId="{00000000-0000-0000-0000-000000000000}"/>
+          </ac:spMkLst>
+        </pc:spChg>
+      </pc:sldChg>
+      <pc:sldChg chg="modTransition">
+        <pc:chgData name="Higuera, Philip" userId="7d9b71f7-bf10-494e-8cb3-2ed11b44844b" providerId="ADAL" clId="{50F7E95B-CBEE-4D68-902A-C9C37096BF45}" dt="2026-06-25T03:43:25.329" v="130"/>
+        <pc:sldMkLst>
+          <pc:docMk/>
+          <pc:sldMk cId="0" sldId="259"/>
+        </pc:sldMkLst>
+      </pc:sldChg>
+      <pc:sldChg chg="modSp mod modTransition">
+        <pc:chgData name="Higuera, Philip" userId="7d9b71f7-bf10-494e-8cb3-2ed11b44844b" providerId="ADAL" clId="{50F7E95B-CBEE-4D68-902A-C9C37096BF45}" dt="2026-06-25T03:46:34.320" v="167" actId="20577"/>
+        <pc:sldMkLst>
+          <pc:docMk/>
+          <pc:sldMk cId="0" sldId="260"/>
+        </pc:sldMkLst>
+        <pc:spChg chg="mod">
+          <ac:chgData name="Higuera, Philip" userId="7d9b71f7-bf10-494e-8cb3-2ed11b44844b" providerId="ADAL" clId="{50F7E95B-CBEE-4D68-902A-C9C37096BF45}" dt="2026-06-25T03:46:34.320" v="167" actId="20577"/>
+          <ac:spMkLst>
+            <pc:docMk/>
+            <pc:sldMk cId="0" sldId="260"/>
+            <ac:spMk id="4" creationId="{00000000-0000-0000-0000-000000000000}"/>
+          </ac:spMkLst>
+        </pc:spChg>
+      </pc:sldChg>
+      <pc:sldChg chg="modTransition">
+        <pc:chgData name="Higuera, Philip" userId="7d9b71f7-bf10-494e-8cb3-2ed11b44844b" providerId="ADAL" clId="{50F7E95B-CBEE-4D68-902A-C9C37096BF45}" dt="2026-06-25T03:43:25.329" v="130"/>
+        <pc:sldMkLst>
+          <pc:docMk/>
+          <pc:sldMk cId="0" sldId="261"/>
+        </pc:sldMkLst>
+      </pc:sldChg>
+      <pc:sldChg chg="modTransition">
+        <pc:chgData name="Higuera, Philip" userId="7d9b71f7-bf10-494e-8cb3-2ed11b44844b" providerId="ADAL" clId="{50F7E95B-CBEE-4D68-902A-C9C37096BF45}" dt="2026-06-25T03:43:25.329" v="130"/>
+        <pc:sldMkLst>
+          <pc:docMk/>
+          <pc:sldMk cId="0" sldId="262"/>
+        </pc:sldMkLst>
+      </pc:sldChg>
+      <pc:sldChg chg="modSp mod modTransition">
+        <pc:chgData name="Higuera, Philip" userId="7d9b71f7-bf10-494e-8cb3-2ed11b44844b" providerId="ADAL" clId="{50F7E95B-CBEE-4D68-902A-C9C37096BF45}" dt="2026-06-25T03:57:03.887" v="415" actId="120"/>
+        <pc:sldMkLst>
+          <pc:docMk/>
+          <pc:sldMk cId="0" sldId="263"/>
+        </pc:sldMkLst>
+        <pc:spChg chg="mod">
+          <ac:chgData name="Higuera, Philip" userId="7d9b71f7-bf10-494e-8cb3-2ed11b44844b" providerId="ADAL" clId="{50F7E95B-CBEE-4D68-902A-C9C37096BF45}" dt="2026-06-25T03:57:03.887" v="415" actId="120"/>
+          <ac:spMkLst>
+            <pc:docMk/>
+            <pc:sldMk cId="0" sldId="263"/>
+            <ac:spMk id="6" creationId="{00000000-0000-0000-0000-000000000000}"/>
+          </ac:spMkLst>
+        </pc:spChg>
+        <pc:graphicFrameChg chg="mod modGraphic">
+          <ac:chgData name="Higuera, Philip" userId="7d9b71f7-bf10-494e-8cb3-2ed11b44844b" providerId="ADAL" clId="{50F7E95B-CBEE-4D68-902A-C9C37096BF45}" dt="2026-06-25T03:56:27.478" v="399" actId="20577"/>
+          <ac:graphicFrameMkLst>
+            <pc:docMk/>
+            <pc:sldMk cId="0" sldId="263"/>
+            <ac:graphicFrameMk id="9" creationId="{00000000-0000-0000-0000-000000000000}"/>
+          </ac:graphicFrameMkLst>
+        </pc:graphicFrameChg>
+        <pc:picChg chg="mod">
+          <ac:chgData name="Higuera, Philip" userId="7d9b71f7-bf10-494e-8cb3-2ed11b44844b" providerId="ADAL" clId="{50F7E95B-CBEE-4D68-902A-C9C37096BF45}" dt="2026-06-25T03:56:36.229" v="411" actId="1038"/>
+          <ac:picMkLst>
+            <pc:docMk/>
+            <pc:sldMk cId="0" sldId="263"/>
+            <ac:picMk id="5" creationId="{00000000-0000-0000-0000-000000000000}"/>
+          </ac:picMkLst>
+        </pc:picChg>
+      </pc:sldChg>
+      <pc:sldChg chg="modTransition">
+        <pc:chgData name="Higuera, Philip" userId="7d9b71f7-bf10-494e-8cb3-2ed11b44844b" providerId="ADAL" clId="{50F7E95B-CBEE-4D68-902A-C9C37096BF45}" dt="2026-06-25T03:43:25.329" v="130"/>
+        <pc:sldMkLst>
+          <pc:docMk/>
+          <pc:sldMk cId="0" sldId="264"/>
+        </pc:sldMkLst>
+      </pc:sldChg>
+      <pc:sldChg chg="modTransition">
+        <pc:chgData name="Higuera, Philip" userId="7d9b71f7-bf10-494e-8cb3-2ed11b44844b" providerId="ADAL" clId="{50F7E95B-CBEE-4D68-902A-C9C37096BF45}" dt="2026-06-25T03:43:25.329" v="130"/>
+        <pc:sldMkLst>
+          <pc:docMk/>
+          <pc:sldMk cId="0" sldId="265"/>
+        </pc:sldMkLst>
+      </pc:sldChg>
+      <pc:sldChg chg="modSp mod modTransition">
+        <pc:chgData name="Higuera, Philip" userId="7d9b71f7-bf10-494e-8cb3-2ed11b44844b" providerId="ADAL" clId="{50F7E95B-CBEE-4D68-902A-C9C37096BF45}" dt="2026-06-25T03:58:39.114" v="493" actId="6549"/>
+        <pc:sldMkLst>
+          <pc:docMk/>
+          <pc:sldMk cId="0" sldId="266"/>
+        </pc:sldMkLst>
+        <pc:spChg chg="mod">
+          <ac:chgData name="Higuera, Philip" userId="7d9b71f7-bf10-494e-8cb3-2ed11b44844b" providerId="ADAL" clId="{50F7E95B-CBEE-4D68-902A-C9C37096BF45}" dt="2026-06-25T03:58:39.114" v="493" actId="6549"/>
+          <ac:spMkLst>
+            <pc:docMk/>
+            <pc:sldMk cId="0" sldId="266"/>
+            <ac:spMk id="5" creationId="{00000000-0000-0000-0000-000000000000}"/>
           </ac:spMkLst>
         </pc:spChg>
       </pc:sldChg>
@@ -2432,6 +2528,23 @@
           </a:p>
           <a:p>
             <a:r>
+              <a:rPr lang="en-US" sz="2400" dirty="0">
+                <a:solidFill>
+                  <a:srgbClr val="444444"/>
+                </a:solidFill>
+                <a:latin typeface="Arial" pitchFamily="34" charset="0"/>
+                <a:ea typeface="Arial" pitchFamily="34" charset="-122"/>
+                <a:cs typeface="Arial" pitchFamily="34" charset="-120"/>
+              </a:rPr>
+              <a:t>GitHub “dev” branch:</a:t>
+            </a:r>
+          </a:p>
+          <a:p>
+            <a:pPr marL="285750" indent="-285750">
+              <a:buFont typeface="Arial" panose="020B0604020202020204" pitchFamily="34" charset="0"/>
+              <a:buChar char="•"/>
+            </a:pPr>
+            <a:r>
               <a:rPr lang="en-US" dirty="0">
                 <a:solidFill>
                   <a:srgbClr val="444444"/>
@@ -2440,7 +2553,7 @@
                 <a:ea typeface="Arial" pitchFamily="34" charset="-122"/>
                 <a:cs typeface="Arial" pitchFamily="34" charset="-120"/>
               </a:rPr>
-              <a:t>GitHub, NEWS: </a:t>
+              <a:t>NEWS </a:t>
             </a:r>
             <a:r>
               <a:rPr lang="en-US" sz="1200" dirty="0">
@@ -2467,8 +2580,12 @@
             </a:r>
           </a:p>
           <a:p>
-            <a:r>
-              <a:rPr lang="en-US" sz="1800" dirty="0">
+            <a:pPr marL="285750" indent="-285750">
+              <a:buFont typeface="Arial" panose="020B0604020202020204" pitchFamily="34" charset="0"/>
+              <a:buChar char="•"/>
+            </a:pPr>
+            <a:r>
+              <a:rPr lang="en-US" dirty="0">
                 <a:solidFill>
                   <a:srgbClr val="444444"/>
                 </a:solidFill>
@@ -2476,7 +2593,7 @@
                 <a:ea typeface="Arial" pitchFamily="34" charset="-122"/>
                 <a:cs typeface="Arial" pitchFamily="34" charset="-120"/>
               </a:rPr>
-              <a:t>GitHub, Chronological Uncertainty Vignette: </a:t>
+              <a:t>Chronological Uncertainty Vignette: </a:t>
             </a:r>
             <a:r>
               <a:rPr lang="en-US" sz="1100" dirty="0">
@@ -2501,53 +2618,6 @@
               </a:rPr>
               <a:t> </a:t>
             </a:r>
-            <a:endParaRPr lang="en-US" sz="1800" dirty="0">
-              <a:solidFill>
-                <a:srgbClr val="444444"/>
-              </a:solidFill>
-              <a:latin typeface="Arial" pitchFamily="34" charset="0"/>
-              <a:ea typeface="Arial" pitchFamily="34" charset="-122"/>
-              <a:cs typeface="Arial" pitchFamily="34" charset="-120"/>
-            </a:endParaRPr>
-          </a:p>
-          <a:p>
-            <a:pPr marL="0" indent="0" algn="l">
-              <a:buNone/>
-            </a:pPr>
-            <a:endParaRPr lang="en-US" dirty="0">
-              <a:solidFill>
-                <a:srgbClr val="444444"/>
-              </a:solidFill>
-              <a:latin typeface="Arial" pitchFamily="34" charset="0"/>
-              <a:ea typeface="Arial" pitchFamily="34" charset="-122"/>
-              <a:cs typeface="Arial" pitchFamily="34" charset="-120"/>
-            </a:endParaRPr>
-          </a:p>
-          <a:p>
-            <a:pPr marL="0" indent="0" algn="l">
-              <a:buNone/>
-            </a:pPr>
-            <a:endParaRPr lang="en-US" dirty="0">
-              <a:solidFill>
-                <a:srgbClr val="444444"/>
-              </a:solidFill>
-              <a:latin typeface="Arial" pitchFamily="34" charset="0"/>
-              <a:ea typeface="Arial" pitchFamily="34" charset="-122"/>
-              <a:cs typeface="Arial" pitchFamily="34" charset="-120"/>
-            </a:endParaRPr>
-          </a:p>
-          <a:p>
-            <a:pPr marL="0" indent="0" algn="l">
-              <a:buNone/>
-            </a:pPr>
-            <a:endParaRPr lang="en-US" sz="1800" dirty="0">
-              <a:solidFill>
-                <a:srgbClr val="444444"/>
-              </a:solidFill>
-              <a:latin typeface="Arial" pitchFamily="34" charset="0"/>
-              <a:ea typeface="Arial" pitchFamily="34" charset="-122"/>
-              <a:cs typeface="Arial" pitchFamily="34" charset="-120"/>
-            </a:endParaRPr>
           </a:p>
           <a:p>
             <a:pPr marL="0" indent="0" algn="l">
@@ -2646,7 +2716,7 @@
         </p:blipFill>
         <p:spPr>
           <a:xfrm>
-            <a:off x="6885188" y="3597575"/>
+            <a:off x="7146880" y="3906487"/>
             <a:ext cx="1122196" cy="1098653"/>
           </a:xfrm>
           <a:prstGeom prst="rect">
@@ -2659,6 +2729,18 @@
   <p:clrMapOvr>
     <a:masterClrMapping/>
   </p:clrMapOvr>
+  <mc:AlternateContent xmlns:mc="http://schemas.openxmlformats.org/markup-compatibility/2006">
+    <mc:Choice xmlns:p14="http://schemas.microsoft.com/office/powerpoint/2010/main" Requires="p14">
+      <p:transition spd="med" p14:dur="700">
+        <p:fade/>
+      </p:transition>
+    </mc:Choice>
+    <mc:Fallback>
+      <p:transition spd="med">
+        <p:fade/>
+      </p:transition>
+    </mc:Fallback>
+  </mc:AlternateContent>
 </p:sld>
 </file>
 
@@ -3018,6 +3100,18 @@
   <p:clrMapOvr>
     <a:masterClrMapping/>
   </p:clrMapOvr>
+  <mc:AlternateContent xmlns:mc="http://schemas.openxmlformats.org/markup-compatibility/2006">
+    <mc:Choice xmlns:p14="http://schemas.microsoft.com/office/powerpoint/2010/main" Requires="p14">
+      <p:transition spd="med" p14:dur="700">
+        <p:fade/>
+      </p:transition>
+    </mc:Choice>
+    <mc:Fallback>
+      <p:transition spd="med">
+        <p:fade/>
+      </p:transition>
+    </mc:Fallback>
+  </mc:AlternateContent>
 </p:sld>
 </file>
 
@@ -3254,7 +3348,7 @@
                 <a:ea typeface="Arial" pitchFamily="34" charset="-122"/>
                 <a:cs typeface="Arial" pitchFamily="34" charset="-120"/>
               </a:rPr>
-              <a:t>Background sensitivity function added to R (</a:t>
+              <a:t>Background sensitivity function added to R, to match </a:t>
             </a:r>
             <a:r>
               <a:rPr lang="en-US" sz="1300" dirty="0" err="1">
@@ -3265,7 +3359,7 @@
                 <a:ea typeface="Arial" pitchFamily="34" charset="-122"/>
                 <a:cs typeface="Arial" pitchFamily="34" charset="-120"/>
               </a:rPr>
-              <a:t>char_bkg_sensitivity</a:t>
+              <a:t>Matlab</a:t>
             </a:r>
             <a:r>
               <a:rPr lang="en-US" sz="1300" dirty="0">
@@ -3276,7 +3370,7 @@
                 <a:ea typeface="Arial" pitchFamily="34" charset="-122"/>
                 <a:cs typeface="Arial" pitchFamily="34" charset="-120"/>
               </a:rPr>
-              <a:t>())</a:t>
+              <a:t> version</a:t>
             </a:r>
           </a:p>
           <a:p>
@@ -3529,6 +3623,18 @@
   <p:clrMapOvr>
     <a:masterClrMapping/>
   </p:clrMapOvr>
+  <mc:AlternateContent xmlns:mc="http://schemas.openxmlformats.org/markup-compatibility/2006">
+    <mc:Choice xmlns:p14="http://schemas.microsoft.com/office/powerpoint/2010/main" Requires="p14">
+      <p:transition spd="med" p14:dur="700">
+        <p:fade/>
+      </p:transition>
+    </mc:Choice>
+    <mc:Fallback>
+      <p:transition spd="med">
+        <p:fade/>
+      </p:transition>
+    </mc:Fallback>
+  </mc:AlternateContent>
 </p:sld>
 </file>
 
@@ -4140,6 +4246,18 @@
   <p:clrMapOvr>
     <a:masterClrMapping/>
   </p:clrMapOvr>
+  <mc:AlternateContent xmlns:mc="http://schemas.openxmlformats.org/markup-compatibility/2006">
+    <mc:Choice xmlns:p14="http://schemas.microsoft.com/office/powerpoint/2010/main" Requires="p14">
+      <p:transition spd="med" p14:dur="700">
+        <p:fade/>
+      </p:transition>
+    </mc:Choice>
+    <mc:Fallback>
+      <p:transition spd="med">
+        <p:fade/>
+      </p:transition>
+    </mc:Fallback>
+  </mc:AlternateContent>
 </p:sld>
 </file>
 
@@ -4654,6 +4772,18 @@
   <p:clrMapOvr>
     <a:masterClrMapping/>
   </p:clrMapOvr>
+  <mc:AlternateContent xmlns:mc="http://schemas.openxmlformats.org/markup-compatibility/2006">
+    <mc:Choice xmlns:p14="http://schemas.microsoft.com/office/powerpoint/2010/main" Requires="p14">
+      <p:transition spd="med" p14:dur="700">
+        <p:fade/>
+      </p:transition>
+    </mc:Choice>
+    <mc:Fallback>
+      <p:transition spd="med">
+        <p:fade/>
+      </p:transition>
+    </mc:Fallback>
+  </mc:AlternateContent>
 </p:sld>
 </file>
 
@@ -5600,6 +5730,18 @@
   <p:clrMapOvr>
     <a:masterClrMapping/>
   </p:clrMapOvr>
+  <mc:AlternateContent xmlns:mc="http://schemas.openxmlformats.org/markup-compatibility/2006">
+    <mc:Choice xmlns:p14="http://schemas.microsoft.com/office/powerpoint/2010/main" Requires="p14">
+      <p:transition spd="med" p14:dur="700">
+        <p:fade/>
+      </p:transition>
+    </mc:Choice>
+    <mc:Fallback>
+      <p:transition spd="med">
+        <p:fade/>
+      </p:transition>
+    </mc:Fallback>
+  </mc:AlternateContent>
 </p:sld>
 </file>
 
@@ -5849,7 +5991,7 @@
                 <a:ea typeface="Arial" pitchFamily="34" charset="-122"/>
                 <a:cs typeface="Arial" pitchFamily="34" charset="-120"/>
               </a:rPr>
-              <a:t>How consistently is each peak detected?</a:t>
+              <a:t>How consistently is each peak identified?</a:t>
             </a:r>
           </a:p>
           <a:p>
@@ -5875,7 +6017,7 @@
                 <a:ea typeface="Arial" pitchFamily="34" charset="-122"/>
                 <a:cs typeface="Arial" pitchFamily="34" charset="-120"/>
               </a:rPr>
-              <a:t>What is the 95% CI on the age of specific peaks?</a:t>
+              <a:t>What is the range of ages assigned to specific peaks?</a:t>
             </a:r>
             <a:endParaRPr lang="en-US" sz="1400" dirty="0"/>
           </a:p>
@@ -6210,6 +6352,18 @@
   <p:clrMapOvr>
     <a:masterClrMapping/>
   </p:clrMapOvr>
+  <mc:AlternateContent xmlns:mc="http://schemas.openxmlformats.org/markup-compatibility/2006">
+    <mc:Choice xmlns:p14="http://schemas.microsoft.com/office/powerpoint/2010/main" Requires="p14">
+      <p:transition spd="med" p14:dur="700">
+        <p:fade/>
+      </p:transition>
+    </mc:Choice>
+    <mc:Fallback>
+      <p:transition spd="med">
+        <p:fade/>
+      </p:transition>
+    </mc:Fallback>
+  </mc:AlternateContent>
   <p:timing>
     <p:tnLst>
       <p:par>
@@ -7668,6 +7822,18 @@
   <p:clrMapOvr>
     <a:masterClrMapping/>
   </p:clrMapOvr>
+  <mc:AlternateContent xmlns:mc="http://schemas.openxmlformats.org/markup-compatibility/2006">
+    <mc:Choice xmlns:p14="http://schemas.microsoft.com/office/powerpoint/2010/main" Requires="p14">
+      <p:transition spd="med" p14:dur="700">
+        <p:fade/>
+      </p:transition>
+    </mc:Choice>
+    <mc:Fallback>
+      <p:transition spd="med">
+        <p:fade/>
+      </p:transition>
+    </mc:Fallback>
+  </mc:AlternateContent>
   <p:timing>
     <p:tnLst>
       <p:par>
@@ -8651,6 +8817,18 @@
   <p:clrMapOvr>
     <a:masterClrMapping/>
   </p:clrMapOvr>
+  <mc:AlternateContent xmlns:mc="http://schemas.openxmlformats.org/markup-compatibility/2006">
+    <mc:Choice xmlns:p14="http://schemas.microsoft.com/office/powerpoint/2010/main" Requires="p14">
+      <p:transition spd="med" p14:dur="700">
+        <p:fade/>
+      </p:transition>
+    </mc:Choice>
+    <mc:Fallback>
+      <p:transition spd="med">
+        <p:fade/>
+      </p:transition>
+    </mc:Fallback>
+  </mc:AlternateContent>
   <p:timing>
     <p:tnLst>
       <p:par>
@@ -8988,35 +9166,35 @@
           <p:nvPr>
             <p:extLst>
               <p:ext uri="{D42A27DB-BD31-4B8C-83A1-F6EECF244321}">
-                <p14:modId xmlns:p14="http://schemas.microsoft.com/office/powerpoint/2010/main" val="1630737673"/>
+                <p14:modId xmlns:p14="http://schemas.microsoft.com/office/powerpoint/2010/main" val="794593561"/>
               </p:ext>
             </p:extLst>
           </p:nvPr>
         </p:nvGraphicFramePr>
         <p:xfrm>
           <a:off x="457200" y="960120"/>
-          <a:ext cx="4770120" cy="3230880"/>
+          <a:ext cx="4846320" cy="3794760"/>
         </p:xfrm>
         <a:graphic>
           <a:graphicData uri="http://schemas.openxmlformats.org/drawingml/2006/table">
             <a:tbl>
               <a:tblPr/>
               <a:tblGrid>
-                <a:gridCol w="1964167">
+                <a:gridCol w="1969001">
                   <a:extLst>
                     <a:ext uri="{9D8B030D-6E8A-4147-A177-3AD203B41FA5}">
                       <a16:colId xmlns:a16="http://schemas.microsoft.com/office/drawing/2014/main" val="20000"/>
                     </a:ext>
                   </a:extLst>
                 </a:gridCol>
-                <a:gridCol w="1493784">
+                <a:gridCol w="1537384">
                   <a:extLst>
                     <a:ext uri="{9D8B030D-6E8A-4147-A177-3AD203B41FA5}">
                       <a16:colId xmlns:a16="http://schemas.microsoft.com/office/drawing/2014/main" val="20001"/>
                     </a:ext>
                   </a:extLst>
                 </a:gridCol>
-                <a:gridCol w="1312169">
+                <a:gridCol w="1339935">
                   <a:extLst>
                     <a:ext uri="{9D8B030D-6E8A-4147-A177-3AD203B41FA5}">
                       <a16:colId xmlns:a16="http://schemas.microsoft.com/office/drawing/2014/main" val="20002"/>
@@ -9266,7 +9444,7 @@
                           <a:latin typeface="Arial" panose="020B0604020202020204" pitchFamily="34" charset="0"/>
                           <a:cs typeface="Arial" panose="020B0604020202020204" pitchFamily="34" charset="0"/>
                         </a:rPr>
-                        <a:t>Precision</a:t>
+                        <a:t>Chronological control</a:t>
                       </a:r>
                       <a:endParaRPr lang="en-US" sz="1000" dirty="0">
                         <a:latin typeface="Arial" panose="020B0604020202020204" pitchFamily="34" charset="0"/>
@@ -9331,6 +9509,61 @@
                         </a:rPr>
                         <a:t>Unusually well-dated</a:t>
                       </a:r>
+                    </a:p>
+                    <a:p>
+                      <a:pPr marL="0" indent="0" algn="ctr">
+                        <a:buNone/>
+                      </a:pPr>
+                      <a:r>
+                        <a:rPr lang="en-US" sz="1000" dirty="0">
+                          <a:solidFill>
+                            <a:srgbClr val="000000"/>
+                          </a:solidFill>
+                          <a:latin typeface="Arial" panose="020B0604020202020204" pitchFamily="34" charset="0"/>
+                          <a:cs typeface="Arial" panose="020B0604020202020204" pitchFamily="34" charset="0"/>
+                        </a:rPr>
+                        <a:t>(25 </a:t>
+                      </a:r>
+                      <a:r>
+                        <a:rPr lang="en-US" sz="1000" baseline="30000" dirty="0">
+                          <a:solidFill>
+                            <a:srgbClr val="000000"/>
+                          </a:solidFill>
+                          <a:latin typeface="Arial" panose="020B0604020202020204" pitchFamily="34" charset="0"/>
+                          <a:cs typeface="Arial" panose="020B0604020202020204" pitchFamily="34" charset="0"/>
+                        </a:rPr>
+                        <a:t>14</a:t>
+                      </a:r>
+                      <a:r>
+                        <a:rPr lang="en-US" sz="1000" dirty="0">
+                          <a:solidFill>
+                            <a:srgbClr val="000000"/>
+                          </a:solidFill>
+                          <a:latin typeface="Arial" panose="020B0604020202020204" pitchFamily="34" charset="0"/>
+                          <a:cs typeface="Arial" panose="020B0604020202020204" pitchFamily="34" charset="0"/>
+                        </a:rPr>
+                        <a:t>C dates, </a:t>
+                      </a:r>
+                      <a:r>
+                        <a:rPr lang="en-US" sz="1000" baseline="30000" dirty="0">
+                          <a:solidFill>
+                            <a:srgbClr val="000000"/>
+                          </a:solidFill>
+                          <a:latin typeface="Arial" panose="020B0604020202020204" pitchFamily="34" charset="0"/>
+                          <a:cs typeface="Arial" panose="020B0604020202020204" pitchFamily="34" charset="0"/>
+                        </a:rPr>
+                        <a:t>210</a:t>
+                      </a:r>
+                      <a:r>
+                        <a:rPr lang="en-US" sz="1000" dirty="0">
+                          <a:solidFill>
+                            <a:srgbClr val="000000"/>
+                          </a:solidFill>
+                          <a:latin typeface="Arial" panose="020B0604020202020204" pitchFamily="34" charset="0"/>
+                          <a:cs typeface="Arial" panose="020B0604020202020204" pitchFamily="34" charset="0"/>
+                        </a:rPr>
+                        <a:t>Pb)</a:t>
+                      </a:r>
                       <a:endParaRPr lang="en-US" sz="1000" dirty="0">
                         <a:latin typeface="Arial" panose="020B0604020202020204" pitchFamily="34" charset="0"/>
                         <a:cs typeface="Arial" panose="020B0604020202020204" pitchFamily="34" charset="0"/>
@@ -9392,7 +9625,62 @@
                           <a:latin typeface="Arial" panose="020B0604020202020204" pitchFamily="34" charset="0"/>
                           <a:cs typeface="Arial" panose="020B0604020202020204" pitchFamily="34" charset="0"/>
                         </a:rPr>
-                        <a:t>Less precisely dated</a:t>
+                        <a:t>Fewer dates</a:t>
+                      </a:r>
+                    </a:p>
+                    <a:p>
+                      <a:pPr marL="0" indent="0" algn="ctr">
+                        <a:buNone/>
+                      </a:pPr>
+                      <a:r>
+                        <a:rPr lang="en-US" sz="1000" dirty="0">
+                          <a:solidFill>
+                            <a:srgbClr val="000000"/>
+                          </a:solidFill>
+                          <a:latin typeface="Arial" panose="020B0604020202020204" pitchFamily="34" charset="0"/>
+                          <a:cs typeface="Arial" panose="020B0604020202020204" pitchFamily="34" charset="0"/>
+                        </a:rPr>
+                        <a:t>(15 </a:t>
+                      </a:r>
+                      <a:r>
+                        <a:rPr lang="en-US" sz="1000" baseline="30000" dirty="0">
+                          <a:solidFill>
+                            <a:srgbClr val="000000"/>
+                          </a:solidFill>
+                          <a:latin typeface="Arial" panose="020B0604020202020204" pitchFamily="34" charset="0"/>
+                          <a:cs typeface="Arial" panose="020B0604020202020204" pitchFamily="34" charset="0"/>
+                        </a:rPr>
+                        <a:t>14</a:t>
+                      </a:r>
+                      <a:r>
+                        <a:rPr lang="en-US" sz="1000" dirty="0">
+                          <a:solidFill>
+                            <a:srgbClr val="000000"/>
+                          </a:solidFill>
+                          <a:latin typeface="Arial" panose="020B0604020202020204" pitchFamily="34" charset="0"/>
+                          <a:cs typeface="Arial" panose="020B0604020202020204" pitchFamily="34" charset="0"/>
+                        </a:rPr>
+                        <a:t>C, 3 tephra, 14 </a:t>
+                      </a:r>
+                      <a:r>
+                        <a:rPr lang="en-US" sz="1000" baseline="30000" dirty="0">
+                          <a:solidFill>
+                            <a:srgbClr val="000000"/>
+                          </a:solidFill>
+                          <a:latin typeface="Arial" panose="020B0604020202020204" pitchFamily="34" charset="0"/>
+                          <a:cs typeface="Arial" panose="020B0604020202020204" pitchFamily="34" charset="0"/>
+                        </a:rPr>
+                        <a:t>210</a:t>
+                      </a:r>
+                      <a:r>
+                        <a:rPr lang="en-US" sz="1000" dirty="0">
+                          <a:solidFill>
+                            <a:srgbClr val="000000"/>
+                          </a:solidFill>
+                          <a:latin typeface="Arial" panose="020B0604020202020204" pitchFamily="34" charset="0"/>
+                          <a:cs typeface="Arial" panose="020B0604020202020204" pitchFamily="34" charset="0"/>
+                        </a:rPr>
+                        <a:t>Pb)</a:t>
                       </a:r>
                       <a:endParaRPr lang="en-US" sz="1000" dirty="0">
                         <a:latin typeface="Arial" panose="020B0604020202020204" pitchFamily="34" charset="0"/>
@@ -9445,7 +9733,203 @@
                   </a:ext>
                 </a:extLst>
               </a:tr>
-              <a:tr h="384048">
+              <a:tr h="363386">
+                <a:tc>
+                  <a:txBody>
+                    <a:bodyPr/>
+                    <a:lstStyle/>
+                    <a:p>
+                      <a:pPr marL="0" indent="0" algn="r">
+                        <a:buNone/>
+                      </a:pPr>
+                      <a:r>
+                        <a:rPr lang="en-US" sz="1000" b="1" dirty="0">
+                          <a:solidFill>
+                            <a:srgbClr val="000000"/>
+                          </a:solidFill>
+                          <a:latin typeface="Arial" panose="020B0604020202020204" pitchFamily="34" charset="0"/>
+                          <a:cs typeface="Arial" panose="020B0604020202020204" pitchFamily="34" charset="0"/>
+                        </a:rPr>
+                        <a:t>Age-depth model source</a:t>
+                      </a:r>
+                      <a:endParaRPr lang="en-US" sz="1000" dirty="0">
+                        <a:latin typeface="Arial" panose="020B0604020202020204" pitchFamily="34" charset="0"/>
+                        <a:cs typeface="Arial" panose="020B0604020202020204" pitchFamily="34" charset="0"/>
+                      </a:endParaRPr>
+                    </a:p>
+                  </a:txBody>
+                  <a:tcPr anchor="ctr">
+                    <a:lnL w="6350" cap="flat" cmpd="sng" algn="ctr">
+                      <a:solidFill>
+                        <a:srgbClr val="D0D8E0"/>
+                      </a:solidFill>
+                      <a:prstDash val="solid"/>
+                      <a:round/>
+                      <a:headEnd type="none" w="med" len="med"/>
+                      <a:tailEnd type="none" w="med" len="med"/>
+                    </a:lnL>
+                    <a:lnR w="6350" cap="flat" cmpd="sng" algn="ctr">
+                      <a:solidFill>
+                        <a:srgbClr val="D0D8E0"/>
+                      </a:solidFill>
+                      <a:prstDash val="solid"/>
+                      <a:round/>
+                      <a:headEnd type="none" w="med" len="med"/>
+                      <a:tailEnd type="none" w="med" len="med"/>
+                    </a:lnR>
+                    <a:lnT w="6350" cap="flat" cmpd="sng" algn="ctr">
+                      <a:solidFill>
+                        <a:srgbClr val="D0D8E0"/>
+                      </a:solidFill>
+                      <a:prstDash val="solid"/>
+                      <a:round/>
+                      <a:headEnd type="none" w="med" len="med"/>
+                      <a:tailEnd type="none" w="med" len="med"/>
+                    </a:lnT>
+                    <a:lnB w="6350" cap="flat" cmpd="sng" algn="ctr">
+                      <a:solidFill>
+                        <a:srgbClr val="D0D8E0"/>
+                      </a:solidFill>
+                      <a:prstDash val="solid"/>
+                      <a:round/>
+                      <a:headEnd type="none" w="med" len="med"/>
+                      <a:tailEnd type="none" w="med" len="med"/>
+                    </a:lnB>
+                  </a:tcPr>
+                </a:tc>
+                <a:tc>
+                  <a:txBody>
+                    <a:bodyPr/>
+                    <a:lstStyle/>
+                    <a:p>
+                      <a:pPr marL="0" indent="0" algn="ctr">
+                        <a:buNone/>
+                      </a:pPr>
+                      <a:r>
+                        <a:rPr lang="en-US" sz="1000" dirty="0" err="1">
+                          <a:solidFill>
+                            <a:srgbClr val="000000"/>
+                          </a:solidFill>
+                          <a:latin typeface="Arial" panose="020B0604020202020204" pitchFamily="34" charset="0"/>
+                          <a:cs typeface="Arial" panose="020B0604020202020204" pitchFamily="34" charset="0"/>
+                        </a:rPr>
+                        <a:t>MCAgeDepth</a:t>
+                      </a:r>
+                      <a:endParaRPr lang="en-US" sz="1000" dirty="0">
+                        <a:latin typeface="Arial" panose="020B0604020202020204" pitchFamily="34" charset="0"/>
+                        <a:cs typeface="Arial" panose="020B0604020202020204" pitchFamily="34" charset="0"/>
+                      </a:endParaRPr>
+                    </a:p>
+                  </a:txBody>
+                  <a:tcPr anchor="ctr">
+                    <a:lnL w="6350" cap="flat" cmpd="sng" algn="ctr">
+                      <a:solidFill>
+                        <a:srgbClr val="D0D8E0"/>
+                      </a:solidFill>
+                      <a:prstDash val="solid"/>
+                      <a:round/>
+                      <a:headEnd type="none" w="med" len="med"/>
+                      <a:tailEnd type="none" w="med" len="med"/>
+                    </a:lnL>
+                    <a:lnR w="6350" cap="flat" cmpd="sng" algn="ctr">
+                      <a:solidFill>
+                        <a:srgbClr val="D0D8E0"/>
+                      </a:solidFill>
+                      <a:prstDash val="solid"/>
+                      <a:round/>
+                      <a:headEnd type="none" w="med" len="med"/>
+                      <a:tailEnd type="none" w="med" len="med"/>
+                    </a:lnR>
+                    <a:lnT w="6350" cap="flat" cmpd="sng" algn="ctr">
+                      <a:solidFill>
+                        <a:srgbClr val="D0D8E0"/>
+                      </a:solidFill>
+                      <a:prstDash val="solid"/>
+                      <a:round/>
+                      <a:headEnd type="none" w="med" len="med"/>
+                      <a:tailEnd type="none" w="med" len="med"/>
+                    </a:lnT>
+                    <a:lnB w="6350" cap="flat" cmpd="sng" algn="ctr">
+                      <a:solidFill>
+                        <a:srgbClr val="D0D8E0"/>
+                      </a:solidFill>
+                      <a:prstDash val="solid"/>
+                      <a:round/>
+                      <a:headEnd type="none" w="med" len="med"/>
+                      <a:tailEnd type="none" w="med" len="med"/>
+                    </a:lnB>
+                  </a:tcPr>
+                </a:tc>
+                <a:tc>
+                  <a:txBody>
+                    <a:bodyPr/>
+                    <a:lstStyle/>
+                    <a:p>
+                      <a:pPr marL="0" indent="0" algn="ctr">
+                        <a:buNone/>
+                      </a:pPr>
+                      <a:r>
+                        <a:rPr lang="en-US" sz="1000" dirty="0">
+                          <a:solidFill>
+                            <a:srgbClr val="000000"/>
+                          </a:solidFill>
+                          <a:latin typeface="Arial" panose="020B0604020202020204" pitchFamily="34" charset="0"/>
+                          <a:cs typeface="Arial" panose="020B0604020202020204" pitchFamily="34" charset="0"/>
+                        </a:rPr>
+                        <a:t>Bacon</a:t>
+                      </a:r>
+                      <a:endParaRPr lang="en-US" sz="1000" dirty="0">
+                        <a:latin typeface="Arial" panose="020B0604020202020204" pitchFamily="34" charset="0"/>
+                        <a:cs typeface="Arial" panose="020B0604020202020204" pitchFamily="34" charset="0"/>
+                      </a:endParaRPr>
+                    </a:p>
+                  </a:txBody>
+                  <a:tcPr anchor="ctr">
+                    <a:lnL w="6350" cap="flat" cmpd="sng" algn="ctr">
+                      <a:solidFill>
+                        <a:srgbClr val="D0D8E0"/>
+                      </a:solidFill>
+                      <a:prstDash val="solid"/>
+                      <a:round/>
+                      <a:headEnd type="none" w="med" len="med"/>
+                      <a:tailEnd type="none" w="med" len="med"/>
+                    </a:lnL>
+                    <a:lnR w="6350" cap="flat" cmpd="sng" algn="ctr">
+                      <a:solidFill>
+                        <a:srgbClr val="D0D8E0"/>
+                      </a:solidFill>
+                      <a:prstDash val="solid"/>
+                      <a:round/>
+                      <a:headEnd type="none" w="med" len="med"/>
+                      <a:tailEnd type="none" w="med" len="med"/>
+                    </a:lnR>
+                    <a:lnT w="6350" cap="flat" cmpd="sng" algn="ctr">
+                      <a:solidFill>
+                        <a:srgbClr val="D0D8E0"/>
+                      </a:solidFill>
+                      <a:prstDash val="solid"/>
+                      <a:round/>
+                      <a:headEnd type="none" w="med" len="med"/>
+                      <a:tailEnd type="none" w="med" len="med"/>
+                    </a:lnT>
+                    <a:lnB w="6350" cap="flat" cmpd="sng" algn="ctr">
+                      <a:solidFill>
+                        <a:srgbClr val="D0D8E0"/>
+                      </a:solidFill>
+                      <a:prstDash val="solid"/>
+                      <a:round/>
+                      <a:headEnd type="none" w="med" len="med"/>
+                      <a:tailEnd type="none" w="med" len="med"/>
+                    </a:lnB>
+                  </a:tcPr>
+                </a:tc>
+                <a:extLst>
+                  <a:ext uri="{0D108BD9-81ED-4DB2-BD59-A6C34878D82A}">
+                    <a16:rowId xmlns:a16="http://schemas.microsoft.com/office/drawing/2014/main" val="10002"/>
+                  </a:ext>
+                </a:extLst>
+              </a:tr>
+              <a:tr h="432142">
                 <a:tc>
                   <a:txBody>
                     <a:bodyPr/>
@@ -9637,7 +10121,7 @@
                 </a:tc>
                 <a:extLst>
                   <a:ext uri="{0D108BD9-81ED-4DB2-BD59-A6C34878D82A}">
-                    <a16:rowId xmlns:a16="http://schemas.microsoft.com/office/drawing/2014/main" val="10002"/>
+                    <a16:rowId xmlns:a16="http://schemas.microsoft.com/office/drawing/2014/main" val="2179715666"/>
                   </a:ext>
                 </a:extLst>
               </a:tr>
@@ -10640,7 +11124,7 @@
         </p:blipFill>
         <p:spPr>
           <a:xfrm>
-            <a:off x="5303520" y="941070"/>
+            <a:off x="5384440" y="941070"/>
             <a:ext cx="3383280" cy="3200400"/>
           </a:xfrm>
           <a:prstGeom prst="rect">
@@ -10656,8 +11140,8 @@
         </p:nvSpPr>
         <p:spPr>
           <a:xfrm>
-            <a:off x="5303520" y="4206240"/>
-            <a:ext cx="3566160" cy="457200"/>
+            <a:off x="5664425" y="4206240"/>
+            <a:ext cx="3022376" cy="457200"/>
           </a:xfrm>
           <a:prstGeom prst="rect">
             <a:avLst/>
@@ -10669,7 +11153,7 @@
           <a:bodyPr wrap="square" lIns="0" tIns="0" rIns="0" bIns="0" rtlCol="0" anchor="t"/>
           <a:lstStyle/>
           <a:p>
-            <a:pPr marL="0" indent="0" algn="ctr">
+            <a:pPr marL="0" indent="0">
               <a:buNone/>
             </a:pPr>
             <a:r>
@@ -10681,7 +11165,7 @@
                 <a:ea typeface="Arial" pitchFamily="34" charset="-122"/>
                 <a:cs typeface="Arial" pitchFamily="34" charset="-120"/>
               </a:rPr>
-              <a:t>Median chronology ± 95% CI. CH10: narrow, uniform. SI17: wider, variable near 1,000 cal yr BP.</a:t>
+              <a:t>Median chronology ± 95% CI. CH10: narrow, uniform. SI17: wider.</a:t>
             </a:r>
             <a:endParaRPr lang="en-US" sz="1000" dirty="0"/>
           </a:p>
@@ -10692,6 +11176,18 @@
   <p:clrMapOvr>
     <a:masterClrMapping/>
   </p:clrMapOvr>
+  <mc:AlternateContent xmlns:mc="http://schemas.openxmlformats.org/markup-compatibility/2006">
+    <mc:Choice xmlns:p14="http://schemas.microsoft.com/office/powerpoint/2010/main" Requires="p14">
+      <p:transition spd="med" p14:dur="700">
+        <p:fade/>
+      </p:transition>
+    </mc:Choice>
+    <mc:Fallback>
+      <p:transition spd="med">
+        <p:fade/>
+      </p:transition>
+    </mc:Fallback>
+  </mc:AlternateContent>
 </p:sld>
 </file>
 
@@ -11028,6 +11524,18 @@
   <p:clrMapOvr>
     <a:masterClrMapping/>
   </p:clrMapOvr>
+  <mc:AlternateContent xmlns:mc="http://schemas.openxmlformats.org/markup-compatibility/2006">
+    <mc:Choice xmlns:p14="http://schemas.microsoft.com/office/powerpoint/2010/main" Requires="p14">
+      <p:transition spd="med" p14:dur="700">
+        <p:fade/>
+      </p:transition>
+    </mc:Choice>
+    <mc:Fallback>
+      <p:transition spd="med">
+        <p:fade/>
+      </p:transition>
+    </mc:Fallback>
+  </mc:AlternateContent>
 </p:sld>
 </file>
 

</xml_diff>